<commit_message>
Claude and Codex checklists: 'not recognized? quit Positron fully, restart'
Co-Authored-By: Claude Opus 5.5 <noreply@anthropic.com>
Claude-Session: https://claude.ai/code/session_01TbrdxHn7W6FVXXnpqzNytd
</commit_message>
<xml_diff>
--- a/slides/01d_connect-ai-assistants_WT26-27.pptx
+++ b/slides/01d_connect-ai-assistants_WT26-27.pptx
@@ -955,7 +955,7 @@
           <a:lstStyle/>
           <a:p>
             <a:r>
-              <a:t>Codex is OpenAI's coding agent for the terminal; there is no separate ChatGPT terminal app, Codex signs in with the ChatGPT account. Account: ChatGPT Plus, Pro, Business, Edu or Enterprise; Free and Go also include Codex with tighter limits (official statement, seen only in search snippets, so check before promising it); or an OpenAI API key, billed per use. Install once with the installer of the previous slide, or brew install --cask codex, or npm install -g @openai/codex. On Windows the native install has its own sandbox; WSL2 only for projects that need Linux tools. Check in a new terminal tab with codex login status. Sign in: codex, then Sign in with ChatGPT; if the browser redirect fails, codex login --device-auth. Live session: tick ai.mcp.enabled (experimental), run Positron MCP: Add to Coding Agent and choose Codex (this writes into ~/.codex/config.toml), then start codex from a Positron terminal so it gets the connection details. Claude Code and Codex can be installed side by side.</a:t>
+              <a:t>Codex is OpenAI's coding agent for the terminal; there is no separate ChatGPT terminal app, Codex signs in with the ChatGPT account. Account: ChatGPT Plus, Pro, Business, Edu or Enterprise; Free and Go also include Codex with tighter limits (official statement, seen only in search snippets, so check before promising it); or an OpenAI API key, billed per use. Install once with the installer of the previous slide, or brew install --cask codex, or npm install -g @openai/codex. On Windows the native install has its own sandbox; WSL2 only for projects that need Linux tools. Check in a new terminal tab with codex login status; if codex is not recognized, quit Positron completely and start it again (a new terminal tab is not enough). Sign in: codex, then Sign in with ChatGPT; if the browser redirect fails, codex login --device-auth. Live session: tick ai.mcp.enabled (experimental), run Positron MCP: Add to Coding Agent and choose Codex (this writes into ~/.codex/config.toml), then start codex from a Positron terminal so it gets the connection details. Claude Code and Codex can be installed side by side.</a:t>
             </a:r>
           </a:p>
         </p:txBody>
@@ -1585,7 +1585,7 @@
           <a:lstStyle/>
           <a:p>
             <a:r>
-              <a:t>Everything needed to run claude in Positron's terminal (Terminal &gt; New Terminal). Account: a paid Claude plan (Pro, Max, Team, Enterprise) or a Claude Console account; the free claude.ai plan does not include Claude Code, and no API key is needed. Install once with the native installer of the previous slide (no admin rights, no WSL; Git for Windows optional, without it Claude runs commands in PowerShell), or with winget install Anthropic.ClaudeCode or brew install --cask claude-code, which do not update themselves. Check in a new terminal tab with claude --version and claude doctor; 'command not found' usually means the old terminal or Positron needs a restart. Start claude in the project folder, sign in in the browser, check with /status that the subscription (not an API key) is used, end with /exit. On its own the terminal agent has no diffs in the editor; for those, also install the Claude Code extension and run /ide. Claude Code does not list Positron among the editors it detects, so test /ide once before teaching it.</a:t>
+              <a:t>Everything needed to run claude in Positron's terminal (Terminal &gt; New Terminal). Account: a paid Claude plan (Pro, Max, Team, Enterprise) or a Claude Console account; the free claude.ai plan does not include Claude Code, and no API key is needed. Install once with the native installer of the previous slide (no admin rights, no WSL; Git for Windows optional, without it Claude runs commands in PowerShell), or with winget install Anthropic.ClaudeCode or brew install --cask claude-code, which do not update themselves. Check in a new terminal tab with claude --version and claude doctor. If the command is not found (Windows PowerShell: 'not recognized as the name of a cmdlet', German: 'wurde nicht als Name eines Cmdlet ... erkannt'), quit Positron completely and start it again; closing the terminal tab is not enough. Start claude in the project folder, sign in in the browser, check with /status that the subscription (not an API key) is used, end with /exit. On its own the terminal agent has no diffs in the editor; for those, also install the Claude Code extension and run /ide. Claude Code does not list Positron among the editors it detects, so test /ide once before teaching it.</a:t>
             </a:r>
           </a:p>
         </p:txBody>
@@ -11607,7 +11607,7 @@
                   <a:schemeClr val="tx1"/>
                 </a:solidFill>
               </a:rPr>
-              <a:t>new terminal tab, codex login status; command not found? restart Positron</a:t>
+              <a:t>new terminal tab, codex login status; not recognized? quit Positron fully and restart</a:t>
             </a:r>
           </a:p>
         </p:txBody>
@@ -16859,7 +16859,7 @@
                   <a:schemeClr val="tx1"/>
                 </a:solidFill>
               </a:rPr>
-              <a:t>new terminal tab, claude --version and claude doctor; command not found? restart Positron</a:t>
+              <a:t>new terminal tab, claude --version and claude doctor; not recognized? quit Positron fully, restart</a:t>
             </a:r>
           </a:p>
         </p:txBody>

</xml_diff>